<commit_message>
Propagate Check 12 (LSTM) and backfill checks 8-10 into report and deck
Report: adds the LSTM finding (R2=-11.97, diagnosed via a naive-mean
baseline and a check for physically impossible negative predictions)
to Limitations, alongside three checks that were missing entirely -
log returns, winsorizing (including the self-correction story), and
the training-window sensitivity check.

Deck: the Conclusion slide's Limitations card was stale (only
mentioned 3 of what are now 12 checks) and Future Improvements still
listed "a genuine stacked ensemble" as open work, when it had already
been tried and failed. Replaced both with a compact, accurate summary
and swapped the stale bullet for on-chain metrics, the report's own
next-most-novel remaining idea.

Co-Authored-By: Claude Sonnet 5 <noreply@anthropic.com>
</commit_message>
<xml_diff>
--- a/presentation/capstone-btc-volatility.pptx
+++ b/presentation/capstone-btc-volatility.pptx
@@ -10430,7 +10430,7 @@
                 <a:ea typeface="Calibri" pitchFamily="34" charset="-122"/>
                 <a:cs typeface="Calibri" pitchFamily="34" charset="-120"/>
               </a:rPr>
-              <a:t>RSI/EMA/MACD/Bollinger width as extra regressors, and a HAR-RV-X + EWMA ensemble, were both tested and didn't survive proper validation</a:t>
+              <a:t>Twelve robustness checks tested (XGBoost, LSTM, stacked ensembles, ETH spillover, winsorizing, and more) — two adopted, ten didn't survive validation</a:t>
             </a:r>
             <a:endParaRPr lang="en-US" sz="1100" dirty="0"/>
           </a:p>
@@ -10662,7 +10662,7 @@
                 <a:ea typeface="Calibri" pitchFamily="34" charset="-122"/>
                 <a:cs typeface="Calibri" pitchFamily="34" charset="-120"/>
               </a:rPr>
-              <a:t>A genuine stacked ensemble (learned, not the fixed blend that failed validation)</a:t>
+              <a:t>On-chain metrics (exchange netflows, active addresses) — a genuinely independent information source, distinct from every price-history feature tested so far</a:t>
             </a:r>
             <a:endParaRPr lang="en-US" sz="1100" dirty="0"/>
           </a:p>

</xml_diff>

<commit_message>
Propagate Checks 15 and 16 into the report and deck
Report (docs/capstone-btc-volatility-report.docx/.pdf): Section 7.6
gets two new paragraphs - the stationary-feature-matrix fix (XGBoost
R2 -0.19 -> 0.01, ElasticNet R2 -0.21 -> -0.03, neither beating
HAR-RV-X) and the row-count-vs-time-aware rolling window diagnostic
(distorts affected rows substantially but touches zero test-window
rows). Section 12.1 Limitations gets a matching summary bullet.

Deck (presentation/capstone-btc-volatility.pptx): the aggregate check
count on slide 13's caption and slide 14's Limitations card updated
from fourteen/twelve to sixteen/fourteen.

Co-Authored-By: Claude Sonnet 5 <noreply@anthropic.com>
</commit_message>
<xml_diff>
--- a/presentation/capstone-btc-volatility.pptx
+++ b/presentation/capstone-btc-volatility.pptx
@@ -9652,7 +9652,7 @@
                 <a:ea typeface="Calibri" pitchFamily="34" charset="-122"/>
                 <a:cs typeface="Calibri" pitchFamily="34" charset="-120"/>
               </a:rPr>
-              <a:t>RMSE isn't directly comparable across resolutions — the target's absolute scale changes by construction. R² is the fair comparison. Documented as Check 11 in the main notebook — one of two checks (of fourteen) that survived validation.</a:t>
+              <a:t>RMSE isn't directly comparable across resolutions — the target's absolute scale changes by construction. R² is the fair comparison. Documented as Check 11 in the main notebook — one of two checks (of sixteen) that survived validation.</a:t>
             </a:r>
             <a:endParaRPr lang="en-US" sz="1050" dirty="0"/>
           </a:p>
@@ -10430,7 +10430,7 @@
                 <a:ea typeface="Calibri" pitchFamily="34" charset="-122"/>
                 <a:cs typeface="Calibri" pitchFamily="34" charset="-120"/>
               </a:rPr>
-              <a:t>Fourteen robustness checks tested (XGBoost, LSTM, stacked ensembles, ETH spillover, winsorizing, and more) — two survived validation and were adopted, twelve didn't</a:t>
+              <a:t>Sixteen robustness checks tested (XGBoost, LSTM, stacked ensembles, ETH spillover, winsorizing, and more) — two survived validation and were adopted, fourteen didn't</a:t>
             </a:r>
             <a:endParaRPr lang="en-US" sz="1100" dirty="0"/>
           </a:p>

</xml_diff>

<commit_message>
Propagate the 5-min companion's HAR-RV-X promotion into report and deck
Report Section 10 (Resolution Sensitivity): Table 3/4's 5-minute
HAR-RV-X row and the discussion text updated to the companion
notebook's own promoted numbers (R2 0.1508 historical, 0.2401 live) -
both resolutions now reflect the same Check-14 promotion rather than
just the hourly side. Also fixed a stale "one check, of eleven" count
in the section intro that was never updated across several rounds of
check additions.

Deck slide 13 (Resolution Sensitivity): same numbers and framing
update, with the caption trimmed to fit its text box after the first
draft overflowed.

Co-Authored-By: Claude Sonnet 5 <noreply@anthropic.com>
</commit_message>
<xml_diff>
--- a/presentation/capstone-btc-volatility.pptx
+++ b/presentation/capstone-btc-volatility.pptx
@@ -8781,7 +8781,7 @@
                 <a:ea typeface="Calibri" pitchFamily="34" charset="-122"/>
                 <a:cs typeface="Calibri" pitchFamily="34" charset="-120"/>
               </a:rPr>
-              <a:t>0.019080</a:t>
+              <a:t>0.018645</a:t>
             </a:r>
             <a:endParaRPr lang="en-US" sz="1150" dirty="0"/>
           </a:p>
@@ -8845,7 +8845,7 @@
                 <a:ea typeface="Calibri" pitchFamily="34" charset="-122"/>
                 <a:cs typeface="Calibri" pitchFamily="34" charset="-120"/>
               </a:rPr>
-              <a:t>0.015477</a:t>
+              <a:t>0.014949</a:t>
             </a:r>
             <a:endParaRPr lang="en-US" sz="1150" dirty="0"/>
           </a:p>
@@ -8909,7 +8909,7 @@
                 <a:ea typeface="Calibri" pitchFamily="34" charset="-122"/>
                 <a:cs typeface="Calibri" pitchFamily="34" charset="-120"/>
               </a:rPr>
-              <a:t>0.2043</a:t>
+              <a:t>0.2401</a:t>
             </a:r>
             <a:endParaRPr lang="en-US" sz="1150" dirty="0"/>
           </a:p>
@@ -9721,7 +9721,7 @@
                 <a:ea typeface="Calibri" pitchFamily="34" charset="-122"/>
                 <a:cs typeface="Calibri" pitchFamily="34" charset="-120"/>
               </a:rPr>
-              <a:t>Key finding:  both models improve on live data at 5-minute resolution, though by different margins now that HAR-RV-X's hourly baseline is stronger (a later robustness check promoted two more regressors into it) — HAR-RV-X's R² goes from 0.122 to 0.204 (about 1.7x); EWMA's improves far more, from 0.013 to 0.147 (about 11x), closing most of the gap to HAR-RV-X. GARCH and Holt-Winters were not re-fit at this resolution (cost/benefit reasoning in the report).</a:t>
+              <a:t>Key finding:  both models improve on live data at 5-minute resolution - HAR-RV-X's own promotion (EWMA_X + SKEW_X, Section 7.4.4) has since been ported here too, so both rows reflect the same model. HAR-RV-X's R² goes from 0.122 to 0.240 (about 2.0x); EWMA's improves far more, from 0.013 to 0.147 (about 11x). GARCH and Holt-Winters were not re-fit at this resolution (cost/benefit reasoning in the report).</a:t>
             </a:r>
             <a:pPr indent="0" marL="0">
               <a:lnSpc>

</xml_diff>

<commit_message>
Add the two worked-example slides from the report to the deck
New slides 15-16 (before Thank you), built by duplicating the "Live
Testing" slide's numbered-steps + callout layout so they match the
deck's existing visual style rather than looking bolted on:

- "Practical Application: Sizing a Trade" - the position-sizing/VaR
  walkthrough from report Section 11.1, same real forecast and
  numbers, plain language, no formulas.
- "Practical Application: Pricing an Option" - the Black-Scholes
  worked example from report Section 11.2, same numbers.

Built via the pptx skill's add_slide.py (proper slide duplication,
not a from-scratch layout) and validated + visually QA'd before
committing.

Co-Authored-By: Claude Sonnet 5 <noreply@anthropic.com>
</commit_message>
<xml_diff>
--- a/presentation/capstone-btc-volatility.pptx
+++ b/presentation/capstone-btc-volatility.pptx
@@ -19,6 +19,8 @@
     <p:sldId id="269" r:id="rId20"/>
     <p:sldId id="270" r:id="rId21"/>
     <p:sldId id="267" r:id="rId13"/>
+    <p:sldId id="271" r:id="rId22"/>
+    <p:sldId id="272" r:id="rId23"/>
     <p:sldId id="268" r:id="rId14"/>
   </p:sldIdLst>
   <p:notesMasterIdLst>
@@ -10677,6 +10679,2260 @@
 </file>
 
 <file path=ppt/slides/slide15.xml><?xml version="1.0" encoding="utf-8"?>
+<p:sld xmlns:a="http://schemas.openxmlformats.org/drawingml/2006/main" xmlns:r="http://schemas.openxmlformats.org/officeDocument/2006/relationships" xmlns:p="http://schemas.openxmlformats.org/presentationml/2006/main">
+  <p:cSld name="Slide 11">
+    <p:bg>
+      <p:bgPr>
+        <a:solidFill>
+          <a:srgbClr val="F7F8FA"/>
+        </a:solidFill>
+      </p:bgPr>
+    </p:bg>
+    <p:spTree>
+      <p:nvGrpSpPr>
+        <p:cNvPr id="1" name=""/>
+        <p:cNvGrpSpPr/>
+        <p:nvPr/>
+      </p:nvGrpSpPr>
+      <p:grpSpPr>
+        <a:xfrm>
+          <a:off x="0" y="0"/>
+          <a:ext cx="0" cy="0"/>
+          <a:chOff x="0" y="0"/>
+          <a:chExt cx="0" cy="0"/>
+        </a:xfrm>
+      </p:grpSpPr>
+      <p:sp>
+        <p:nvSpPr>
+          <p:cNvPr id="2" name="Shape 0"/>
+          <p:cNvSpPr/>
+          <p:nvPr/>
+        </p:nvSpPr>
+        <p:spPr>
+          <a:xfrm>
+            <a:off x="10972800" y="365760"/>
+            <a:ext cx="731520" cy="731520"/>
+          </a:xfrm>
+          <a:prstGeom prst="ellipse">
+            <a:avLst/>
+          </a:prstGeom>
+          <a:solidFill>
+            <a:srgbClr val="0D1B2A"/>
+          </a:solidFill>
+          <a:ln/>
+        </p:spPr>
+        <p:txBody>
+          <a:bodyPr/>
+          <a:p/>
+        </p:txBody>
+      </p:sp>
+      <p:sp>
+        <p:nvSpPr>
+          <p:cNvPr id="3" name="Shape 1"/>
+          <p:cNvSpPr/>
+          <p:nvPr/>
+        </p:nvSpPr>
+        <p:spPr>
+          <a:xfrm flipV="1">
+            <a:off x="11133734" y="588142"/>
+            <a:ext cx="122895" cy="204826"/>
+          </a:xfrm>
+          <a:prstGeom prst="line">
+            <a:avLst/>
+          </a:prstGeom>
+          <a:noFill/>
+          <a:ln w="25400">
+            <a:solidFill>
+              <a:srgbClr val="F7931A"/>
+            </a:solidFill>
+            <a:prstDash val="solid"/>
+          </a:ln>
+        </p:spPr>
+        <p:txBody>
+          <a:bodyPr/>
+          <a:p/>
+        </p:txBody>
+      </p:sp>
+      <p:sp>
+        <p:nvSpPr>
+          <p:cNvPr id="4" name="Shape 2"/>
+          <p:cNvSpPr/>
+          <p:nvPr/>
+        </p:nvSpPr>
+        <p:spPr>
+          <a:xfrm>
+            <a:off x="11256630" y="588142"/>
+            <a:ext cx="81930" cy="245791"/>
+          </a:xfrm>
+          <a:prstGeom prst="line">
+            <a:avLst/>
+          </a:prstGeom>
+          <a:noFill/>
+          <a:ln w="25400">
+            <a:solidFill>
+              <a:srgbClr val="F7931A"/>
+            </a:solidFill>
+            <a:prstDash val="solid"/>
+          </a:ln>
+        </p:spPr>
+        <p:txBody>
+          <a:bodyPr/>
+          <a:p/>
+        </p:txBody>
+      </p:sp>
+      <p:sp>
+        <p:nvSpPr>
+          <p:cNvPr id="5" name="Shape 3"/>
+          <p:cNvSpPr/>
+          <p:nvPr/>
+        </p:nvSpPr>
+        <p:spPr>
+          <a:xfrm flipV="1">
+            <a:off x="11338560" y="526694"/>
+            <a:ext cx="102413" cy="307238"/>
+          </a:xfrm>
+          <a:prstGeom prst="line">
+            <a:avLst/>
+          </a:prstGeom>
+          <a:noFill/>
+          <a:ln w="25400">
+            <a:solidFill>
+              <a:srgbClr val="F7931A"/>
+            </a:solidFill>
+            <a:prstDash val="solid"/>
+          </a:ln>
+        </p:spPr>
+        <p:txBody>
+          <a:bodyPr/>
+          <a:p/>
+        </p:txBody>
+      </p:sp>
+      <p:sp>
+        <p:nvSpPr>
+          <p:cNvPr id="6" name="Shape 4"/>
+          <p:cNvSpPr/>
+          <p:nvPr/>
+        </p:nvSpPr>
+        <p:spPr>
+          <a:xfrm>
+            <a:off x="11440973" y="526694"/>
+            <a:ext cx="102413" cy="184343"/>
+          </a:xfrm>
+          <a:prstGeom prst="line">
+            <a:avLst/>
+          </a:prstGeom>
+          <a:noFill/>
+          <a:ln w="25400">
+            <a:solidFill>
+              <a:srgbClr val="F7931A"/>
+            </a:solidFill>
+            <a:prstDash val="solid"/>
+          </a:ln>
+        </p:spPr>
+        <p:txBody>
+          <a:bodyPr/>
+          <a:p/>
+        </p:txBody>
+      </p:sp>
+      <p:sp>
+        <p:nvSpPr>
+          <p:cNvPr id="7" name="Text 5"/>
+          <p:cNvSpPr/>
+          <p:nvPr/>
+        </p:nvSpPr>
+        <p:spPr>
+          <a:xfrm>
+            <a:off x="548640" y="365760"/>
+            <a:ext cx="10058400" cy="640080"/>
+          </a:xfrm>
+          <a:prstGeom prst="rect">
+            <a:avLst/>
+          </a:prstGeom>
+          <a:noFill/>
+          <a:ln/>
+        </p:spPr>
+        <p:txBody>
+          <a:bodyPr wrap="square" rtlCol="0" anchor="ctr"/>
+          <a:lstStyle/>
+          <a:p>
+            <a:pPr indent="0" marL="0">
+              <a:buNone/>
+            </a:pPr>
+            <a:r>
+              <a:rPr lang="en-US" sz="3000" b="1" dirty="0">
+                <a:solidFill>
+                  <a:srgbClr val="0D1B2A"/>
+                </a:solidFill>
+                <a:latin typeface="Cambria" pitchFamily="34" charset="0"/>
+                <a:ea typeface="Cambria" pitchFamily="34" charset="-122"/>
+                <a:cs typeface="Cambria" pitchFamily="34" charset="-120"/>
+              </a:rPr>
+              <a:t>Practical Application: Sizing a Trade</a:t>
+            </a:r>
+            <a:endParaRPr lang="en-US" sz="3000" dirty="0"/>
+          </a:p>
+        </p:txBody>
+      </p:sp>
+      <p:sp>
+        <p:nvSpPr>
+          <p:cNvPr id="8" name="Text 6"/>
+          <p:cNvSpPr/>
+          <p:nvPr/>
+        </p:nvSpPr>
+        <p:spPr>
+          <a:xfrm>
+            <a:off x="548640" y="932688"/>
+            <a:ext cx="10515600" cy="365760"/>
+          </a:xfrm>
+          <a:prstGeom prst="rect">
+            <a:avLst/>
+          </a:prstGeom>
+          <a:noFill/>
+          <a:ln/>
+        </p:spPr>
+        <p:txBody>
+          <a:bodyPr wrap="square" rtlCol="0" anchor="ctr"/>
+          <a:lstStyle/>
+          <a:p>
+            <a:pPr indent="0" marL="0">
+              <a:buNone/>
+            </a:pPr>
+            <a:r>
+              <a:rPr lang="en-US" sz="1400" i="1" dirty="0">
+                <a:solidFill>
+                  <a:srgbClr val="5C6B7A"/>
+                </a:solidFill>
+                <a:latin typeface="Calibri" pitchFamily="34" charset="0"/>
+                <a:ea typeface="Calibri" pitchFamily="34" charset="-122"/>
+                <a:cs typeface="Calibri" pitchFamily="34" charset="-120"/>
+              </a:rPr>
+              <a:t>Turning this week's real forecast into a position size and a risk estimate</a:t>
+            </a:r>
+            <a:endParaRPr lang="en-US" sz="1400" dirty="0"/>
+          </a:p>
+        </p:txBody>
+      </p:sp>
+      <p:sp>
+        <p:nvSpPr>
+          <p:cNvPr id="9" name="Text 7"/>
+          <p:cNvSpPr/>
+          <p:nvPr/>
+        </p:nvSpPr>
+        <p:spPr>
+          <a:xfrm>
+            <a:off x="457200" y="6537960"/>
+            <a:ext cx="7315200" cy="274320"/>
+          </a:xfrm>
+          <a:prstGeom prst="rect">
+            <a:avLst/>
+          </a:prstGeom>
+          <a:noFill/>
+          <a:ln/>
+        </p:spPr>
+        <p:txBody>
+          <a:bodyPr wrap="square" rtlCol="0" anchor="ctr"/>
+          <a:lstStyle/>
+          <a:p>
+            <a:pPr indent="0" marL="0">
+              <a:buNone/>
+            </a:pPr>
+            <a:r>
+              <a:rPr lang="en-US" sz="900" dirty="0">
+                <a:solidFill>
+                  <a:srgbClr val="5C6B7A"/>
+                </a:solidFill>
+                <a:latin typeface="Calibri" pitchFamily="34" charset="0"/>
+                <a:ea typeface="Calibri" pitchFamily="34" charset="-122"/>
+                <a:cs typeface="Calibri" pitchFamily="34" charset="-120"/>
+              </a:rPr>
+              <a:t>BTC Volatility Prediction  |  Capstone</a:t>
+            </a:r>
+            <a:endParaRPr lang="en-US" sz="900" dirty="0"/>
+          </a:p>
+        </p:txBody>
+      </p:sp>
+      <p:sp>
+        <p:nvSpPr>
+          <p:cNvPr id="10" name="Text 8"/>
+          <p:cNvSpPr/>
+          <p:nvPr/>
+        </p:nvSpPr>
+        <p:spPr>
+          <a:xfrm>
+            <a:off x="11521440" y="6537960"/>
+            <a:ext cx="457200" cy="274320"/>
+          </a:xfrm>
+          <a:prstGeom prst="rect">
+            <a:avLst/>
+          </a:prstGeom>
+          <a:noFill/>
+          <a:ln/>
+        </p:spPr>
+        <p:txBody>
+          <a:bodyPr wrap="square" rtlCol="0" anchor="ctr"/>
+          <a:lstStyle/>
+          <a:p>
+            <a:pPr algn="r" indent="0" marL="0">
+              <a:buNone/>
+            </a:pPr>
+            <a:r>
+              <a:rPr lang="en-US" sz="900" dirty="0">
+                <a:solidFill>
+                  <a:srgbClr val="5C6B7A"/>
+                </a:solidFill>
+                <a:latin typeface="Calibri" pitchFamily="34" charset="0"/>
+                <a:ea typeface="Calibri" pitchFamily="34" charset="-122"/>
+                <a:cs typeface="Calibri" pitchFamily="34" charset="-120"/>
+              </a:rPr>
+              <a:t>16</a:t>
+            </a:r>
+            <a:endParaRPr lang="en-US" sz="900" dirty="0"/>
+          </a:p>
+        </p:txBody>
+      </p:sp>
+      <p:sp>
+        <p:nvSpPr>
+          <p:cNvPr id="11" name="Shape 9"/>
+          <p:cNvSpPr/>
+          <p:nvPr/>
+        </p:nvSpPr>
+        <p:spPr>
+          <a:xfrm>
+            <a:off x="548640" y="1645920"/>
+            <a:ext cx="2697480" cy="2377440"/>
+          </a:xfrm>
+          <a:prstGeom prst="roundRect">
+            <a:avLst>
+              <a:gd name="adj" fmla="val 3077"/>
+            </a:avLst>
+          </a:prstGeom>
+          <a:solidFill>
+            <a:srgbClr val="FFFFFF"/>
+          </a:solidFill>
+          <a:ln w="12700">
+            <a:solidFill>
+              <a:srgbClr val="CADCFC"/>
+            </a:solidFill>
+            <a:prstDash val="solid"/>
+          </a:ln>
+        </p:spPr>
+        <p:txBody>
+          <a:bodyPr/>
+          <a:p/>
+        </p:txBody>
+      </p:sp>
+      <p:sp>
+        <p:nvSpPr>
+          <p:cNvPr id="12" name="Shape 10"/>
+          <p:cNvSpPr/>
+          <p:nvPr/>
+        </p:nvSpPr>
+        <p:spPr>
+          <a:xfrm>
+            <a:off x="1645920" y="1828800"/>
+            <a:ext cx="502920" cy="502920"/>
+          </a:xfrm>
+          <a:prstGeom prst="ellipse">
+            <a:avLst/>
+          </a:prstGeom>
+          <a:solidFill>
+            <a:srgbClr val="1B4965"/>
+          </a:solidFill>
+          <a:ln/>
+        </p:spPr>
+        <p:txBody>
+          <a:bodyPr/>
+          <a:p/>
+        </p:txBody>
+      </p:sp>
+      <p:sp>
+        <p:nvSpPr>
+          <p:cNvPr id="13" name="Text 11"/>
+          <p:cNvSpPr/>
+          <p:nvPr/>
+        </p:nvSpPr>
+        <p:spPr>
+          <a:xfrm>
+            <a:off x="1645920" y="1828800"/>
+            <a:ext cx="502920" cy="502920"/>
+          </a:xfrm>
+          <a:prstGeom prst="rect">
+            <a:avLst/>
+          </a:prstGeom>
+          <a:noFill/>
+          <a:ln/>
+        </p:spPr>
+        <p:txBody>
+          <a:bodyPr wrap="square" rtlCol="0" anchor="ctr"/>
+          <a:lstStyle/>
+          <a:p>
+            <a:pPr algn="ctr" indent="0" marL="0">
+              <a:buNone/>
+            </a:pPr>
+            <a:r>
+              <a:rPr lang="en-US" sz="1700" b="1" dirty="0">
+                <a:solidFill>
+                  <a:srgbClr val="F7931A"/>
+                </a:solidFill>
+                <a:latin typeface="Cambria" pitchFamily="34" charset="0"/>
+                <a:ea typeface="Cambria" pitchFamily="34" charset="-122"/>
+                <a:cs typeface="Cambria" pitchFamily="34" charset="-120"/>
+              </a:rPr>
+              <a:t>1</a:t>
+            </a:r>
+            <a:endParaRPr lang="en-US" sz="1700" dirty="0"/>
+          </a:p>
+        </p:txBody>
+      </p:sp>
+      <p:sp>
+        <p:nvSpPr>
+          <p:cNvPr id="14" name="Text 12"/>
+          <p:cNvSpPr/>
+          <p:nvPr/>
+        </p:nvSpPr>
+        <p:spPr>
+          <a:xfrm>
+            <a:off x="731520" y="2450592"/>
+            <a:ext cx="2331720" cy="320040"/>
+          </a:xfrm>
+          <a:prstGeom prst="rect">
+            <a:avLst/>
+          </a:prstGeom>
+          <a:noFill/>
+          <a:ln/>
+        </p:spPr>
+        <p:txBody>
+          <a:bodyPr wrap="square" rtlCol="0" anchor="ctr"/>
+          <a:lstStyle/>
+          <a:p>
+            <a:pPr algn="ctr" indent="0" marL="0">
+              <a:buNone/>
+            </a:pPr>
+            <a:r>
+              <a:rPr lang="en-US" sz="1300" b="1" dirty="0">
+                <a:solidFill>
+                  <a:srgbClr val="0D1B2A"/>
+                </a:solidFill>
+                <a:latin typeface="Cambria" pitchFamily="34" charset="0"/>
+                <a:ea typeface="Cambria" pitchFamily="34" charset="-122"/>
+                <a:cs typeface="Cambria" pitchFamily="34" charset="-120"/>
+              </a:rPr>
+              <a:t>Forecast the move</a:t>
+            </a:r>
+            <a:endParaRPr lang="en-US" sz="1300" dirty="0"/>
+          </a:p>
+        </p:txBody>
+      </p:sp>
+      <p:sp>
+        <p:nvSpPr>
+          <p:cNvPr id="15" name="Text 13"/>
+          <p:cNvSpPr/>
+          <p:nvPr/>
+        </p:nvSpPr>
+        <p:spPr>
+          <a:xfrm>
+            <a:off x="731520" y="2788920"/>
+            <a:ext cx="2331720" cy="1097280"/>
+          </a:xfrm>
+          <a:prstGeom prst="rect">
+            <a:avLst/>
+          </a:prstGeom>
+          <a:noFill/>
+          <a:ln/>
+        </p:spPr>
+        <p:txBody>
+          <a:bodyPr wrap="square" rtlCol="0" anchor="t"/>
+          <a:lstStyle/>
+          <a:p>
+            <a:pPr algn="ctr" indent="0" marL="0">
+              <a:lnSpc>
+                <a:spcPct val="110000"/>
+              </a:lnSpc>
+              <a:buNone/>
+            </a:pPr>
+            <a:r>
+              <a:rPr lang="en-US" sz="1100" dirty="0">
+                <a:solidFill>
+                  <a:srgbClr val="0D1B2A"/>
+                </a:solidFill>
+                <a:latin typeface="Calibri" pitchFamily="34" charset="0"/>
+                <a:ea typeface="Calibri" pitchFamily="34" charset="-122"/>
+                <a:cs typeface="Calibri" pitchFamily="34" charset="-120"/>
+              </a:rPr>
+              <a:t>On 2026-08-25, the model predicted BTC would swing about 6% over the coming week — its real, live forecast, not a hypothetical.</a:t>
+            </a:r>
+            <a:endParaRPr lang="en-US" sz="1100" dirty="0"/>
+          </a:p>
+        </p:txBody>
+      </p:sp>
+      <p:sp>
+        <p:nvSpPr>
+          <p:cNvPr id="16" name="Shape 14"/>
+          <p:cNvSpPr/>
+          <p:nvPr/>
+        </p:nvSpPr>
+        <p:spPr>
+          <a:xfrm>
+            <a:off x="3383280" y="1645920"/>
+            <a:ext cx="2697480" cy="2377440"/>
+          </a:xfrm>
+          <a:prstGeom prst="roundRect">
+            <a:avLst>
+              <a:gd name="adj" fmla="val 3077"/>
+            </a:avLst>
+          </a:prstGeom>
+          <a:solidFill>
+            <a:srgbClr val="FFFFFF"/>
+          </a:solidFill>
+          <a:ln w="12700">
+            <a:solidFill>
+              <a:srgbClr val="CADCFC"/>
+            </a:solidFill>
+            <a:prstDash val="solid"/>
+          </a:ln>
+        </p:spPr>
+        <p:txBody>
+          <a:bodyPr/>
+          <a:p/>
+        </p:txBody>
+      </p:sp>
+      <p:sp>
+        <p:nvSpPr>
+          <p:cNvPr id="17" name="Shape 15"/>
+          <p:cNvSpPr/>
+          <p:nvPr/>
+        </p:nvSpPr>
+        <p:spPr>
+          <a:xfrm>
+            <a:off x="4480560" y="1828800"/>
+            <a:ext cx="502920" cy="502920"/>
+          </a:xfrm>
+          <a:prstGeom prst="ellipse">
+            <a:avLst/>
+          </a:prstGeom>
+          <a:solidFill>
+            <a:srgbClr val="1B4965"/>
+          </a:solidFill>
+          <a:ln/>
+        </p:spPr>
+        <p:txBody>
+          <a:bodyPr/>
+          <a:p/>
+        </p:txBody>
+      </p:sp>
+      <p:sp>
+        <p:nvSpPr>
+          <p:cNvPr id="18" name="Text 16"/>
+          <p:cNvSpPr/>
+          <p:nvPr/>
+        </p:nvSpPr>
+        <p:spPr>
+          <a:xfrm>
+            <a:off x="4480560" y="1828800"/>
+            <a:ext cx="502920" cy="502920"/>
+          </a:xfrm>
+          <a:prstGeom prst="rect">
+            <a:avLst/>
+          </a:prstGeom>
+          <a:noFill/>
+          <a:ln/>
+        </p:spPr>
+        <p:txBody>
+          <a:bodyPr wrap="square" rtlCol="0" anchor="ctr"/>
+          <a:lstStyle/>
+          <a:p>
+            <a:pPr algn="ctr" indent="0" marL="0">
+              <a:buNone/>
+            </a:pPr>
+            <a:r>
+              <a:rPr lang="en-US" sz="1700" b="1" dirty="0">
+                <a:solidFill>
+                  <a:srgbClr val="F7931A"/>
+                </a:solidFill>
+                <a:latin typeface="Cambria" pitchFamily="34" charset="0"/>
+                <a:ea typeface="Cambria" pitchFamily="34" charset="-122"/>
+                <a:cs typeface="Cambria" pitchFamily="34" charset="-120"/>
+              </a:rPr>
+              <a:t>2</a:t>
+            </a:r>
+            <a:endParaRPr lang="en-US" sz="1700" dirty="0"/>
+          </a:p>
+        </p:txBody>
+      </p:sp>
+      <p:sp>
+        <p:nvSpPr>
+          <p:cNvPr id="19" name="Text 17"/>
+          <p:cNvSpPr/>
+          <p:nvPr/>
+        </p:nvSpPr>
+        <p:spPr>
+          <a:xfrm>
+            <a:off x="3566160" y="2450592"/>
+            <a:ext cx="2331720" cy="320040"/>
+          </a:xfrm>
+          <a:prstGeom prst="rect">
+            <a:avLst/>
+          </a:prstGeom>
+          <a:noFill/>
+          <a:ln/>
+        </p:spPr>
+        <p:txBody>
+          <a:bodyPr wrap="square" rtlCol="0" anchor="ctr"/>
+          <a:lstStyle/>
+          <a:p>
+            <a:pPr algn="ctr" indent="0" marL="0">
+              <a:buNone/>
+            </a:pPr>
+            <a:r>
+              <a:rPr lang="en-US" sz="1300" b="1" dirty="0">
+                <a:solidFill>
+                  <a:srgbClr val="0D1B2A"/>
+                </a:solidFill>
+                <a:latin typeface="Cambria" pitchFamily="34" charset="0"/>
+                <a:ea typeface="Cambria" pitchFamily="34" charset="-122"/>
+                <a:cs typeface="Cambria" pitchFamily="34" charset="-120"/>
+              </a:rPr>
+              <a:t>Size the position</a:t>
+            </a:r>
+            <a:endParaRPr lang="en-US" sz="1300" dirty="0"/>
+          </a:p>
+        </p:txBody>
+      </p:sp>
+      <p:sp>
+        <p:nvSpPr>
+          <p:cNvPr id="20" name="Text 18"/>
+          <p:cNvSpPr/>
+          <p:nvPr/>
+        </p:nvSpPr>
+        <p:spPr>
+          <a:xfrm>
+            <a:off x="3566160" y="2788920"/>
+            <a:ext cx="2331720" cy="1097280"/>
+          </a:xfrm>
+          <a:prstGeom prst="rect">
+            <a:avLst/>
+          </a:prstGeom>
+          <a:noFill/>
+          <a:ln/>
+        </p:spPr>
+        <p:txBody>
+          <a:bodyPr wrap="square" rtlCol="0" anchor="t"/>
+          <a:lstStyle/>
+          <a:p>
+            <a:pPr algn="ctr" indent="0" marL="0">
+              <a:lnSpc>
+                <a:spcPct val="110000"/>
+              </a:lnSpc>
+              <a:buNone/>
+            </a:pPr>
+            <a:r>
+              <a:rPr lang="en-US" sz="1100" dirty="0">
+                <a:solidFill>
+                  <a:srgbClr val="0D1B2A"/>
+                </a:solidFill>
+                <a:latin typeface="Calibri" pitchFamily="34" charset="0"/>
+                <a:ea typeface="Calibri" pitchFamily="34" charset="-122"/>
+                <a:cs typeface="Calibri" pitchFamily="34" charset="-120"/>
+              </a:rPr>
+              <a:t>Risking $50,000 on a move of that size points to a position worth about $823,000 — bigger forecasted moves mean smaller positions.</a:t>
+            </a:r>
+            <a:endParaRPr lang="en-US" sz="1100" dirty="0"/>
+          </a:p>
+        </p:txBody>
+      </p:sp>
+      <p:sp>
+        <p:nvSpPr>
+          <p:cNvPr id="21" name="Shape 19"/>
+          <p:cNvSpPr/>
+          <p:nvPr/>
+        </p:nvSpPr>
+        <p:spPr>
+          <a:xfrm>
+            <a:off x="6217920" y="1645920"/>
+            <a:ext cx="2697480" cy="2377440"/>
+          </a:xfrm>
+          <a:prstGeom prst="roundRect">
+            <a:avLst>
+              <a:gd name="adj" fmla="val 3077"/>
+            </a:avLst>
+          </a:prstGeom>
+          <a:solidFill>
+            <a:srgbClr val="FFFFFF"/>
+          </a:solidFill>
+          <a:ln w="12700">
+            <a:solidFill>
+              <a:srgbClr val="CADCFC"/>
+            </a:solidFill>
+            <a:prstDash val="solid"/>
+          </a:ln>
+        </p:spPr>
+        <p:txBody>
+          <a:bodyPr/>
+          <a:p/>
+        </p:txBody>
+      </p:sp>
+      <p:sp>
+        <p:nvSpPr>
+          <p:cNvPr id="22" name="Shape 20"/>
+          <p:cNvSpPr/>
+          <p:nvPr/>
+        </p:nvSpPr>
+        <p:spPr>
+          <a:xfrm>
+            <a:off x="7315200" y="1828800"/>
+            <a:ext cx="502920" cy="502920"/>
+          </a:xfrm>
+          <a:prstGeom prst="ellipse">
+            <a:avLst/>
+          </a:prstGeom>
+          <a:solidFill>
+            <a:srgbClr val="1B4965"/>
+          </a:solidFill>
+          <a:ln/>
+        </p:spPr>
+        <p:txBody>
+          <a:bodyPr/>
+          <a:p/>
+        </p:txBody>
+      </p:sp>
+      <p:sp>
+        <p:nvSpPr>
+          <p:cNvPr id="23" name="Text 21"/>
+          <p:cNvSpPr/>
+          <p:nvPr/>
+        </p:nvSpPr>
+        <p:spPr>
+          <a:xfrm>
+            <a:off x="7315200" y="1828800"/>
+            <a:ext cx="502920" cy="502920"/>
+          </a:xfrm>
+          <a:prstGeom prst="rect">
+            <a:avLst/>
+          </a:prstGeom>
+          <a:noFill/>
+          <a:ln/>
+        </p:spPr>
+        <p:txBody>
+          <a:bodyPr wrap="square" rtlCol="0" anchor="ctr"/>
+          <a:lstStyle/>
+          <a:p>
+            <a:pPr algn="ctr" indent="0" marL="0">
+              <a:buNone/>
+            </a:pPr>
+            <a:r>
+              <a:rPr lang="en-US" sz="1700" b="1" dirty="0">
+                <a:solidFill>
+                  <a:srgbClr val="F7931A"/>
+                </a:solidFill>
+                <a:latin typeface="Cambria" pitchFamily="34" charset="0"/>
+                <a:ea typeface="Cambria" pitchFamily="34" charset="-122"/>
+                <a:cs typeface="Cambria" pitchFamily="34" charset="-120"/>
+              </a:rPr>
+              <a:t>3</a:t>
+            </a:r>
+            <a:endParaRPr lang="en-US" sz="1700" dirty="0"/>
+          </a:p>
+        </p:txBody>
+      </p:sp>
+      <p:sp>
+        <p:nvSpPr>
+          <p:cNvPr id="24" name="Text 22"/>
+          <p:cNvSpPr/>
+          <p:nvPr/>
+        </p:nvSpPr>
+        <p:spPr>
+          <a:xfrm>
+            <a:off x="6400800" y="2450592"/>
+            <a:ext cx="2331720" cy="320040"/>
+          </a:xfrm>
+          <a:prstGeom prst="rect">
+            <a:avLst/>
+          </a:prstGeom>
+          <a:noFill/>
+          <a:ln/>
+        </p:spPr>
+        <p:txBody>
+          <a:bodyPr wrap="square" rtlCol="0" anchor="ctr"/>
+          <a:lstStyle/>
+          <a:p>
+            <a:pPr algn="ctr" indent="0" marL="0">
+              <a:buNone/>
+            </a:pPr>
+            <a:r>
+              <a:rPr lang="en-US" sz="1300" b="1" dirty="0">
+                <a:solidFill>
+                  <a:srgbClr val="0D1B2A"/>
+                </a:solidFill>
+                <a:latin typeface="Cambria" pitchFamily="34" charset="0"/>
+                <a:ea typeface="Cambria" pitchFamily="34" charset="-122"/>
+                <a:cs typeface="Cambria" pitchFamily="34" charset="-120"/>
+              </a:rPr>
+              <a:t>Estimate the downside</a:t>
+            </a:r>
+            <a:endParaRPr lang="en-US" sz="1300" dirty="0"/>
+          </a:p>
+        </p:txBody>
+      </p:sp>
+      <p:sp>
+        <p:nvSpPr>
+          <p:cNvPr id="25" name="Text 23"/>
+          <p:cNvSpPr/>
+          <p:nvPr/>
+        </p:nvSpPr>
+        <p:spPr>
+          <a:xfrm>
+            <a:off x="6400800" y="2788920"/>
+            <a:ext cx="2331720" cy="1097280"/>
+          </a:xfrm>
+          <a:prstGeom prst="rect">
+            <a:avLst/>
+          </a:prstGeom>
+          <a:noFill/>
+          <a:ln/>
+        </p:spPr>
+        <p:txBody>
+          <a:bodyPr wrap="square" rtlCol="0" anchor="t"/>
+          <a:lstStyle/>
+          <a:p>
+            <a:pPr algn="ctr" indent="0" marL="0">
+              <a:lnSpc>
+                <a:spcPct val="110000"/>
+              </a:lnSpc>
+              <a:buNone/>
+            </a:pPr>
+            <a:r>
+              <a:rPr lang="en-US" sz="1100" dirty="0">
+                <a:solidFill>
+                  <a:srgbClr val="0D1B2A"/>
+                </a:solidFill>
+                <a:latin typeface="Calibri" pitchFamily="34" charset="0"/>
+                <a:ea typeface="Calibri" pitchFamily="34" charset="-122"/>
+                <a:cs typeface="Calibri" pitchFamily="34" charset="-120"/>
+              </a:rPr>
+              <a:t>That position carries roughly a 5% chance of losing more than about $82,000 over the week — the number that goes in a risk report.</a:t>
+            </a:r>
+            <a:endParaRPr lang="en-US" sz="1100" dirty="0"/>
+          </a:p>
+        </p:txBody>
+      </p:sp>
+      <p:sp>
+        <p:nvSpPr>
+          <p:cNvPr id="26" name="Shape 24"/>
+          <p:cNvSpPr/>
+          <p:nvPr/>
+        </p:nvSpPr>
+        <p:spPr>
+          <a:xfrm>
+            <a:off x="9052560" y="1645920"/>
+            <a:ext cx="2697480" cy="2377440"/>
+          </a:xfrm>
+          <a:prstGeom prst="roundRect">
+            <a:avLst>
+              <a:gd name="adj" fmla="val 3077"/>
+            </a:avLst>
+          </a:prstGeom>
+          <a:solidFill>
+            <a:srgbClr val="FFFFFF"/>
+          </a:solidFill>
+          <a:ln w="12700">
+            <a:solidFill>
+              <a:srgbClr val="CADCFC"/>
+            </a:solidFill>
+            <a:prstDash val="solid"/>
+          </a:ln>
+        </p:spPr>
+        <p:txBody>
+          <a:bodyPr/>
+          <a:p/>
+        </p:txBody>
+      </p:sp>
+      <p:sp>
+        <p:nvSpPr>
+          <p:cNvPr id="27" name="Shape 25"/>
+          <p:cNvSpPr/>
+          <p:nvPr/>
+        </p:nvSpPr>
+        <p:spPr>
+          <a:xfrm>
+            <a:off x="10149840" y="1828800"/>
+            <a:ext cx="502920" cy="502920"/>
+          </a:xfrm>
+          <a:prstGeom prst="ellipse">
+            <a:avLst/>
+          </a:prstGeom>
+          <a:solidFill>
+            <a:srgbClr val="1B4965"/>
+          </a:solidFill>
+          <a:ln/>
+        </p:spPr>
+        <p:txBody>
+          <a:bodyPr/>
+          <a:p/>
+        </p:txBody>
+      </p:sp>
+      <p:sp>
+        <p:nvSpPr>
+          <p:cNvPr id="28" name="Text 26"/>
+          <p:cNvSpPr/>
+          <p:nvPr/>
+        </p:nvSpPr>
+        <p:spPr>
+          <a:xfrm>
+            <a:off x="10149840" y="1828800"/>
+            <a:ext cx="502920" cy="502920"/>
+          </a:xfrm>
+          <a:prstGeom prst="rect">
+            <a:avLst/>
+          </a:prstGeom>
+          <a:noFill/>
+          <a:ln/>
+        </p:spPr>
+        <p:txBody>
+          <a:bodyPr wrap="square" rtlCol="0" anchor="ctr"/>
+          <a:lstStyle/>
+          <a:p>
+            <a:pPr algn="ctr" indent="0" marL="0">
+              <a:buNone/>
+            </a:pPr>
+            <a:r>
+              <a:rPr lang="en-US" sz="1700" b="1" dirty="0">
+                <a:solidFill>
+                  <a:srgbClr val="F7931A"/>
+                </a:solidFill>
+                <a:latin typeface="Cambria" pitchFamily="34" charset="0"/>
+                <a:ea typeface="Cambria" pitchFamily="34" charset="-122"/>
+                <a:cs typeface="Cambria" pitchFamily="34" charset="-120"/>
+              </a:rPr>
+              <a:t>4</a:t>
+            </a:r>
+            <a:endParaRPr lang="en-US" sz="1700" dirty="0"/>
+          </a:p>
+        </p:txBody>
+      </p:sp>
+      <p:sp>
+        <p:nvSpPr>
+          <p:cNvPr id="29" name="Text 27"/>
+          <p:cNvSpPr/>
+          <p:nvPr/>
+        </p:nvSpPr>
+        <p:spPr>
+          <a:xfrm>
+            <a:off x="9235440" y="2450592"/>
+            <a:ext cx="2331720" cy="320040"/>
+          </a:xfrm>
+          <a:prstGeom prst="rect">
+            <a:avLst/>
+          </a:prstGeom>
+          <a:noFill/>
+          <a:ln/>
+        </p:spPr>
+        <p:txBody>
+          <a:bodyPr wrap="square" rtlCol="0" anchor="ctr"/>
+          <a:lstStyle/>
+          <a:p>
+            <a:pPr algn="ctr" indent="0" marL="0">
+              <a:buNone/>
+            </a:pPr>
+            <a:r>
+              <a:rPr lang="en-US" sz="1300" b="1" dirty="0">
+                <a:solidFill>
+                  <a:srgbClr val="0D1B2A"/>
+                </a:solidFill>
+                <a:latin typeface="Cambria" pitchFamily="34" charset="0"/>
+                <a:ea typeface="Cambria" pitchFamily="34" charset="-122"/>
+                <a:cs typeface="Cambria" pitchFamily="34" charset="-120"/>
+              </a:rPr>
+              <a:t>Compare to the options market</a:t>
+            </a:r>
+            <a:endParaRPr lang="en-US" sz="1300" dirty="0"/>
+          </a:p>
+        </p:txBody>
+      </p:sp>
+      <p:sp>
+        <p:nvSpPr>
+          <p:cNvPr id="30" name="Text 28"/>
+          <p:cNvSpPr/>
+          <p:nvPr/>
+        </p:nvSpPr>
+        <p:spPr>
+          <a:xfrm>
+            <a:off x="9235440" y="2788920"/>
+            <a:ext cx="2331720" cy="1097280"/>
+          </a:xfrm>
+          <a:prstGeom prst="rect">
+            <a:avLst/>
+          </a:prstGeom>
+          <a:noFill/>
+          <a:ln/>
+        </p:spPr>
+        <p:txBody>
+          <a:bodyPr wrap="square" rtlCol="0" anchor="t"/>
+          <a:lstStyle/>
+          <a:p>
+            <a:pPr algn="ctr" indent="0" marL="0">
+              <a:lnSpc>
+                <a:spcPct val="110000"/>
+              </a:lnSpc>
+              <a:buNone/>
+            </a:pPr>
+            <a:r>
+              <a:rPr lang="en-US" sz="1100" dirty="0">
+                <a:solidFill>
+                  <a:srgbClr val="0D1B2A"/>
+                </a:solidFill>
+                <a:latin typeface="Calibri" pitchFamily="34" charset="0"/>
+                <a:ea typeface="Calibri" pitchFamily="34" charset="-122"/>
+                <a:cs typeface="Calibri" pitchFamily="34" charset="-120"/>
+              </a:rPr>
+              <a:t>If options are pricing in far more movement than this, they may be overpriced relative to what the model expects — worth a closer look.</a:t>
+            </a:r>
+            <a:endParaRPr lang="en-US" sz="1100" dirty="0"/>
+          </a:p>
+        </p:txBody>
+      </p:sp>
+      <p:sp>
+        <p:nvSpPr>
+          <p:cNvPr id="31" name="Shape 29"/>
+          <p:cNvSpPr/>
+          <p:nvPr/>
+        </p:nvSpPr>
+        <p:spPr>
+          <a:xfrm>
+            <a:off x="548640" y="4297680"/>
+            <a:ext cx="11064240" cy="1737360"/>
+          </a:xfrm>
+          <a:prstGeom prst="roundRect">
+            <a:avLst>
+              <a:gd name="adj" fmla="val 4211"/>
+            </a:avLst>
+          </a:prstGeom>
+          <a:solidFill>
+            <a:srgbClr val="0D1B2A"/>
+          </a:solidFill>
+          <a:ln/>
+        </p:spPr>
+        <p:txBody>
+          <a:bodyPr/>
+          <a:p/>
+        </p:txBody>
+      </p:sp>
+      <p:sp>
+        <p:nvSpPr>
+          <p:cNvPr id="32" name="Text 30"/>
+          <p:cNvSpPr/>
+          <p:nvPr/>
+        </p:nvSpPr>
+        <p:spPr>
+          <a:xfrm>
+            <a:off x="868680" y="4480560"/>
+            <a:ext cx="10424160" cy="320040"/>
+          </a:xfrm>
+          <a:prstGeom prst="rect">
+            <a:avLst/>
+          </a:prstGeom>
+          <a:noFill/>
+          <a:ln/>
+        </p:spPr>
+        <p:txBody>
+          <a:bodyPr wrap="square" rtlCol="0" anchor="ctr"/>
+          <a:lstStyle/>
+          <a:p>
+            <a:pPr indent="0" marL="0">
+              <a:buNone/>
+            </a:pPr>
+            <a:r>
+              <a:rPr lang="en-US" sz="1500" b="1" dirty="0">
+                <a:solidFill>
+                  <a:srgbClr val="F7931A"/>
+                </a:solidFill>
+                <a:latin typeface="Cambria" pitchFamily="34" charset="0"/>
+                <a:ea typeface="Cambria" pitchFamily="34" charset="-122"/>
+                <a:cs typeface="Cambria" pitchFamily="34" charset="-120"/>
+              </a:rPr>
+              <a:t>Why this is one input, not the final answer</a:t>
+            </a:r>
+            <a:endParaRPr lang="en-US" sz="1500" dirty="0"/>
+          </a:p>
+        </p:txBody>
+      </p:sp>
+      <p:sp>
+        <p:nvSpPr>
+          <p:cNvPr id="33" name="Text 31"/>
+          <p:cNvSpPr/>
+          <p:nvPr/>
+        </p:nvSpPr>
+        <p:spPr>
+          <a:xfrm>
+            <a:off x="868680" y="4846320"/>
+            <a:ext cx="10424160" cy="1051560"/>
+          </a:xfrm>
+          <a:prstGeom prst="rect">
+            <a:avLst/>
+          </a:prstGeom>
+          <a:noFill/>
+          <a:ln/>
+        </p:spPr>
+        <p:txBody>
+          <a:bodyPr wrap="square" rtlCol="0" anchor="t"/>
+          <a:lstStyle/>
+          <a:p>
+            <a:pPr indent="0" marL="0">
+              <a:lnSpc>
+                <a:spcPct val="120000"/>
+              </a:lnSpc>
+              <a:buNone/>
+            </a:pPr>
+            <a:r>
+              <a:rPr lang="en-US" sz="1300" dirty="0">
+                <a:solidFill>
+                  <a:srgbClr val="FFFFFF"/>
+                </a:solidFill>
+                <a:latin typeface="Calibri" pitchFamily="34" charset="0"/>
+                <a:ea typeface="Calibri" pitchFamily="34" charset="-122"/>
+                <a:cs typeface="Calibri" pitchFamily="34" charset="-120"/>
+              </a:rPr>
+              <a:t>The model explains about 18% of real volatility swings, with typical errors around a quarter of the forecast — useful, but no substitute for market context, judgement, and other risk signals. A more traditional model (GARCH) performed far worse over this same horizon, so this is a genuine improvement, not a finished system.</a:t>
+            </a:r>
+            <a:endParaRPr lang="en-US" sz="1300" dirty="0"/>
+          </a:p>
+        </p:txBody>
+      </p:sp>
+    </p:spTree>
+  </p:cSld>
+  <p:clrMapOvr>
+    <a:masterClrMapping/>
+  </p:clrMapOvr>
+</p:sld>
+</file>
+
+<file path=ppt/slides/slide16.xml><?xml version="1.0" encoding="utf-8"?>
+<p:sld xmlns:a="http://schemas.openxmlformats.org/drawingml/2006/main" xmlns:r="http://schemas.openxmlformats.org/officeDocument/2006/relationships" xmlns:p="http://schemas.openxmlformats.org/presentationml/2006/main">
+  <p:cSld name="Slide 11">
+    <p:bg>
+      <p:bgPr>
+        <a:solidFill>
+          <a:srgbClr val="F7F8FA"/>
+        </a:solidFill>
+      </p:bgPr>
+    </p:bg>
+    <p:spTree>
+      <p:nvGrpSpPr>
+        <p:cNvPr id="1" name=""/>
+        <p:cNvGrpSpPr/>
+        <p:nvPr/>
+      </p:nvGrpSpPr>
+      <p:grpSpPr>
+        <a:xfrm>
+          <a:off x="0" y="0"/>
+          <a:ext cx="0" cy="0"/>
+          <a:chOff x="0" y="0"/>
+          <a:chExt cx="0" cy="0"/>
+        </a:xfrm>
+      </p:grpSpPr>
+      <p:sp>
+        <p:nvSpPr>
+          <p:cNvPr id="2" name="Shape 0"/>
+          <p:cNvSpPr/>
+          <p:nvPr/>
+        </p:nvSpPr>
+        <p:spPr>
+          <a:xfrm>
+            <a:off x="10972800" y="365760"/>
+            <a:ext cx="731520" cy="731520"/>
+          </a:xfrm>
+          <a:prstGeom prst="ellipse">
+            <a:avLst/>
+          </a:prstGeom>
+          <a:solidFill>
+            <a:srgbClr val="0D1B2A"/>
+          </a:solidFill>
+          <a:ln/>
+        </p:spPr>
+        <p:txBody>
+          <a:bodyPr/>
+          <a:p/>
+        </p:txBody>
+      </p:sp>
+      <p:sp>
+        <p:nvSpPr>
+          <p:cNvPr id="3" name="Shape 1"/>
+          <p:cNvSpPr/>
+          <p:nvPr/>
+        </p:nvSpPr>
+        <p:spPr>
+          <a:xfrm flipV="1">
+            <a:off x="11133734" y="588142"/>
+            <a:ext cx="122895" cy="204826"/>
+          </a:xfrm>
+          <a:prstGeom prst="line">
+            <a:avLst/>
+          </a:prstGeom>
+          <a:noFill/>
+          <a:ln w="25400">
+            <a:solidFill>
+              <a:srgbClr val="F7931A"/>
+            </a:solidFill>
+            <a:prstDash val="solid"/>
+          </a:ln>
+        </p:spPr>
+        <p:txBody>
+          <a:bodyPr/>
+          <a:p/>
+        </p:txBody>
+      </p:sp>
+      <p:sp>
+        <p:nvSpPr>
+          <p:cNvPr id="4" name="Shape 2"/>
+          <p:cNvSpPr/>
+          <p:nvPr/>
+        </p:nvSpPr>
+        <p:spPr>
+          <a:xfrm>
+            <a:off x="11256630" y="588142"/>
+            <a:ext cx="81930" cy="245791"/>
+          </a:xfrm>
+          <a:prstGeom prst="line">
+            <a:avLst/>
+          </a:prstGeom>
+          <a:noFill/>
+          <a:ln w="25400">
+            <a:solidFill>
+              <a:srgbClr val="F7931A"/>
+            </a:solidFill>
+            <a:prstDash val="solid"/>
+          </a:ln>
+        </p:spPr>
+        <p:txBody>
+          <a:bodyPr/>
+          <a:p/>
+        </p:txBody>
+      </p:sp>
+      <p:sp>
+        <p:nvSpPr>
+          <p:cNvPr id="5" name="Shape 3"/>
+          <p:cNvSpPr/>
+          <p:nvPr/>
+        </p:nvSpPr>
+        <p:spPr>
+          <a:xfrm flipV="1">
+            <a:off x="11338560" y="526694"/>
+            <a:ext cx="102413" cy="307238"/>
+          </a:xfrm>
+          <a:prstGeom prst="line">
+            <a:avLst/>
+          </a:prstGeom>
+          <a:noFill/>
+          <a:ln w="25400">
+            <a:solidFill>
+              <a:srgbClr val="F7931A"/>
+            </a:solidFill>
+            <a:prstDash val="solid"/>
+          </a:ln>
+        </p:spPr>
+        <p:txBody>
+          <a:bodyPr/>
+          <a:p/>
+        </p:txBody>
+      </p:sp>
+      <p:sp>
+        <p:nvSpPr>
+          <p:cNvPr id="6" name="Shape 4"/>
+          <p:cNvSpPr/>
+          <p:nvPr/>
+        </p:nvSpPr>
+        <p:spPr>
+          <a:xfrm>
+            <a:off x="11440973" y="526694"/>
+            <a:ext cx="102413" cy="184343"/>
+          </a:xfrm>
+          <a:prstGeom prst="line">
+            <a:avLst/>
+          </a:prstGeom>
+          <a:noFill/>
+          <a:ln w="25400">
+            <a:solidFill>
+              <a:srgbClr val="F7931A"/>
+            </a:solidFill>
+            <a:prstDash val="solid"/>
+          </a:ln>
+        </p:spPr>
+        <p:txBody>
+          <a:bodyPr/>
+          <a:p/>
+        </p:txBody>
+      </p:sp>
+      <p:sp>
+        <p:nvSpPr>
+          <p:cNvPr id="7" name="Text 5"/>
+          <p:cNvSpPr/>
+          <p:nvPr/>
+        </p:nvSpPr>
+        <p:spPr>
+          <a:xfrm>
+            <a:off x="548640" y="365760"/>
+            <a:ext cx="10058400" cy="640080"/>
+          </a:xfrm>
+          <a:prstGeom prst="rect">
+            <a:avLst/>
+          </a:prstGeom>
+          <a:noFill/>
+          <a:ln/>
+        </p:spPr>
+        <p:txBody>
+          <a:bodyPr wrap="square" rtlCol="0" anchor="ctr"/>
+          <a:lstStyle/>
+          <a:p>
+            <a:pPr indent="0" marL="0">
+              <a:buNone/>
+            </a:pPr>
+            <a:r>
+              <a:rPr lang="en-US" sz="3000" b="1" dirty="0">
+                <a:solidFill>
+                  <a:srgbClr val="0D1B2A"/>
+                </a:solidFill>
+                <a:latin typeface="Cambria" pitchFamily="34" charset="0"/>
+                <a:ea typeface="Cambria" pitchFamily="34" charset="-122"/>
+                <a:cs typeface="Cambria" pitchFamily="34" charset="-120"/>
+              </a:rPr>
+              <a:t>Practical Application: Pricing an Option</a:t>
+            </a:r>
+            <a:endParaRPr lang="en-US" sz="3000" dirty="0"/>
+          </a:p>
+        </p:txBody>
+      </p:sp>
+      <p:sp>
+        <p:nvSpPr>
+          <p:cNvPr id="8" name="Text 6"/>
+          <p:cNvSpPr/>
+          <p:nvPr/>
+        </p:nvSpPr>
+        <p:spPr>
+          <a:xfrm>
+            <a:off x="548640" y="932688"/>
+            <a:ext cx="10515600" cy="365760"/>
+          </a:xfrm>
+          <a:prstGeom prst="rect">
+            <a:avLst/>
+          </a:prstGeom>
+          <a:noFill/>
+          <a:ln/>
+        </p:spPr>
+        <p:txBody>
+          <a:bodyPr wrap="square" rtlCol="0" anchor="ctr"/>
+          <a:lstStyle/>
+          <a:p>
+            <a:pPr indent="0" marL="0">
+              <a:buNone/>
+            </a:pPr>
+            <a:r>
+              <a:rPr lang="en-US" sz="1400" i="1" dirty="0">
+                <a:solidFill>
+                  <a:srgbClr val="5C6B7A"/>
+                </a:solidFill>
+                <a:latin typeface="Calibri" pitchFamily="34" charset="0"/>
+                <a:ea typeface="Calibri" pitchFamily="34" charset="-122"/>
+                <a:cs typeface="Calibri" pitchFamily="34" charset="-120"/>
+              </a:rPr>
+              <a:t>Comparing the model's forecast to how the options market is pricing risk</a:t>
+            </a:r>
+            <a:endParaRPr lang="en-US" sz="1400" dirty="0"/>
+          </a:p>
+        </p:txBody>
+      </p:sp>
+      <p:sp>
+        <p:nvSpPr>
+          <p:cNvPr id="9" name="Text 7"/>
+          <p:cNvSpPr/>
+          <p:nvPr/>
+        </p:nvSpPr>
+        <p:spPr>
+          <a:xfrm>
+            <a:off x="457200" y="6537960"/>
+            <a:ext cx="7315200" cy="274320"/>
+          </a:xfrm>
+          <a:prstGeom prst="rect">
+            <a:avLst/>
+          </a:prstGeom>
+          <a:noFill/>
+          <a:ln/>
+        </p:spPr>
+        <p:txBody>
+          <a:bodyPr wrap="square" rtlCol="0" anchor="ctr"/>
+          <a:lstStyle/>
+          <a:p>
+            <a:pPr indent="0" marL="0">
+              <a:buNone/>
+            </a:pPr>
+            <a:r>
+              <a:rPr lang="en-US" sz="900" dirty="0">
+                <a:solidFill>
+                  <a:srgbClr val="5C6B7A"/>
+                </a:solidFill>
+                <a:latin typeface="Calibri" pitchFamily="34" charset="0"/>
+                <a:ea typeface="Calibri" pitchFamily="34" charset="-122"/>
+                <a:cs typeface="Calibri" pitchFamily="34" charset="-120"/>
+              </a:rPr>
+              <a:t>BTC Volatility Prediction  |  Capstone</a:t>
+            </a:r>
+            <a:endParaRPr lang="en-US" sz="900" dirty="0"/>
+          </a:p>
+        </p:txBody>
+      </p:sp>
+      <p:sp>
+        <p:nvSpPr>
+          <p:cNvPr id="10" name="Text 8"/>
+          <p:cNvSpPr/>
+          <p:nvPr/>
+        </p:nvSpPr>
+        <p:spPr>
+          <a:xfrm>
+            <a:off x="11521440" y="6537960"/>
+            <a:ext cx="457200" cy="274320"/>
+          </a:xfrm>
+          <a:prstGeom prst="rect">
+            <a:avLst/>
+          </a:prstGeom>
+          <a:noFill/>
+          <a:ln/>
+        </p:spPr>
+        <p:txBody>
+          <a:bodyPr wrap="square" rtlCol="0" anchor="ctr"/>
+          <a:lstStyle/>
+          <a:p>
+            <a:pPr algn="r" indent="0" marL="0">
+              <a:buNone/>
+            </a:pPr>
+            <a:r>
+              <a:rPr lang="en-US" sz="900" dirty="0">
+                <a:solidFill>
+                  <a:srgbClr val="5C6B7A"/>
+                </a:solidFill>
+                <a:latin typeface="Calibri" pitchFamily="34" charset="0"/>
+                <a:ea typeface="Calibri" pitchFamily="34" charset="-122"/>
+                <a:cs typeface="Calibri" pitchFamily="34" charset="-120"/>
+              </a:rPr>
+              <a:t>17</a:t>
+            </a:r>
+            <a:endParaRPr lang="en-US" sz="900" dirty="0"/>
+          </a:p>
+        </p:txBody>
+      </p:sp>
+      <p:sp>
+        <p:nvSpPr>
+          <p:cNvPr id="11" name="Shape 9"/>
+          <p:cNvSpPr/>
+          <p:nvPr/>
+        </p:nvSpPr>
+        <p:spPr>
+          <a:xfrm>
+            <a:off x="548640" y="1645920"/>
+            <a:ext cx="2697480" cy="2377440"/>
+          </a:xfrm>
+          <a:prstGeom prst="roundRect">
+            <a:avLst>
+              <a:gd name="adj" fmla="val 3077"/>
+            </a:avLst>
+          </a:prstGeom>
+          <a:solidFill>
+            <a:srgbClr val="FFFFFF"/>
+          </a:solidFill>
+          <a:ln w="12700">
+            <a:solidFill>
+              <a:srgbClr val="CADCFC"/>
+            </a:solidFill>
+            <a:prstDash val="solid"/>
+          </a:ln>
+        </p:spPr>
+        <p:txBody>
+          <a:bodyPr/>
+          <a:p/>
+        </p:txBody>
+      </p:sp>
+      <p:sp>
+        <p:nvSpPr>
+          <p:cNvPr id="12" name="Shape 10"/>
+          <p:cNvSpPr/>
+          <p:nvPr/>
+        </p:nvSpPr>
+        <p:spPr>
+          <a:xfrm>
+            <a:off x="1645920" y="1828800"/>
+            <a:ext cx="502920" cy="502920"/>
+          </a:xfrm>
+          <a:prstGeom prst="ellipse">
+            <a:avLst/>
+          </a:prstGeom>
+          <a:solidFill>
+            <a:srgbClr val="1B4965"/>
+          </a:solidFill>
+          <a:ln/>
+        </p:spPr>
+        <p:txBody>
+          <a:bodyPr/>
+          <a:p/>
+        </p:txBody>
+      </p:sp>
+      <p:sp>
+        <p:nvSpPr>
+          <p:cNvPr id="13" name="Text 11"/>
+          <p:cNvSpPr/>
+          <p:nvPr/>
+        </p:nvSpPr>
+        <p:spPr>
+          <a:xfrm>
+            <a:off x="1645920" y="1828800"/>
+            <a:ext cx="502920" cy="502920"/>
+          </a:xfrm>
+          <a:prstGeom prst="rect">
+            <a:avLst/>
+          </a:prstGeom>
+          <a:noFill/>
+          <a:ln/>
+        </p:spPr>
+        <p:txBody>
+          <a:bodyPr wrap="square" rtlCol="0" anchor="ctr"/>
+          <a:lstStyle/>
+          <a:p>
+            <a:pPr algn="ctr" indent="0" marL="0">
+              <a:buNone/>
+            </a:pPr>
+            <a:r>
+              <a:rPr lang="en-US" sz="1700" b="1" dirty="0">
+                <a:solidFill>
+                  <a:srgbClr val="F7931A"/>
+                </a:solidFill>
+                <a:latin typeface="Cambria" pitchFamily="34" charset="0"/>
+                <a:ea typeface="Cambria" pitchFamily="34" charset="-122"/>
+                <a:cs typeface="Cambria" pitchFamily="34" charset="-120"/>
+              </a:rPr>
+              <a:t>1</a:t>
+            </a:r>
+            <a:endParaRPr lang="en-US" sz="1700" dirty="0"/>
+          </a:p>
+        </p:txBody>
+      </p:sp>
+      <p:sp>
+        <p:nvSpPr>
+          <p:cNvPr id="14" name="Text 12"/>
+          <p:cNvSpPr/>
+          <p:nvPr/>
+        </p:nvSpPr>
+        <p:spPr>
+          <a:xfrm>
+            <a:off x="731520" y="2450592"/>
+            <a:ext cx="2331720" cy="320040"/>
+          </a:xfrm>
+          <a:prstGeom prst="rect">
+            <a:avLst/>
+          </a:prstGeom>
+          <a:noFill/>
+          <a:ln/>
+        </p:spPr>
+        <p:txBody>
+          <a:bodyPr wrap="square" rtlCol="0" anchor="ctr"/>
+          <a:lstStyle/>
+          <a:p>
+            <a:pPr algn="ctr" indent="0" marL="0">
+              <a:buNone/>
+            </a:pPr>
+            <a:r>
+              <a:rPr lang="en-US" sz="1300" b="1" dirty="0">
+                <a:solidFill>
+                  <a:srgbClr val="0D1B2A"/>
+                </a:solidFill>
+                <a:latin typeface="Cambria" pitchFamily="34" charset="0"/>
+                <a:ea typeface="Cambria" pitchFamily="34" charset="-122"/>
+                <a:cs typeface="Cambria" pitchFamily="34" charset="-120"/>
+              </a:rPr>
+              <a:t>Convert to a yearly figure</a:t>
+            </a:r>
+            <a:endParaRPr lang="en-US" sz="1300" dirty="0"/>
+          </a:p>
+        </p:txBody>
+      </p:sp>
+      <p:sp>
+        <p:nvSpPr>
+          <p:cNvPr id="15" name="Text 13"/>
+          <p:cNvSpPr/>
+          <p:nvPr/>
+        </p:nvSpPr>
+        <p:spPr>
+          <a:xfrm>
+            <a:off x="731520" y="2788920"/>
+            <a:ext cx="2331720" cy="1097280"/>
+          </a:xfrm>
+          <a:prstGeom prst="rect">
+            <a:avLst/>
+          </a:prstGeom>
+          <a:noFill/>
+          <a:ln/>
+        </p:spPr>
+        <p:txBody>
+          <a:bodyPr wrap="square" rtlCol="0" anchor="t"/>
+          <a:lstStyle/>
+          <a:p>
+            <a:pPr algn="ctr" indent="0" marL="0">
+              <a:lnSpc>
+                <a:spcPct val="110000"/>
+              </a:lnSpc>
+              <a:buNone/>
+            </a:pPr>
+            <a:r>
+              <a:rPr lang="en-US" sz="1100" dirty="0">
+                <a:solidFill>
+                  <a:srgbClr val="0D1B2A"/>
+                </a:solidFill>
+                <a:latin typeface="Calibri" pitchFamily="34" charset="0"/>
+                <a:ea typeface="Calibri" pitchFamily="34" charset="-122"/>
+                <a:cs typeface="Calibri" pitchFamily="34" charset="-120"/>
+              </a:rPr>
+              <a:t>The model's short-term forecast, scaled to the yearly figure options pricing uses, comes out to about 44% annualized volatility.</a:t>
+            </a:r>
+            <a:endParaRPr lang="en-US" sz="1100" dirty="0"/>
+          </a:p>
+        </p:txBody>
+      </p:sp>
+      <p:sp>
+        <p:nvSpPr>
+          <p:cNvPr id="16" name="Shape 14"/>
+          <p:cNvSpPr/>
+          <p:nvPr/>
+        </p:nvSpPr>
+        <p:spPr>
+          <a:xfrm>
+            <a:off x="3383280" y="1645920"/>
+            <a:ext cx="2697480" cy="2377440"/>
+          </a:xfrm>
+          <a:prstGeom prst="roundRect">
+            <a:avLst>
+              <a:gd name="adj" fmla="val 3077"/>
+            </a:avLst>
+          </a:prstGeom>
+          <a:solidFill>
+            <a:srgbClr val="FFFFFF"/>
+          </a:solidFill>
+          <a:ln w="12700">
+            <a:solidFill>
+              <a:srgbClr val="CADCFC"/>
+            </a:solidFill>
+            <a:prstDash val="solid"/>
+          </a:ln>
+        </p:spPr>
+        <p:txBody>
+          <a:bodyPr/>
+          <a:p/>
+        </p:txBody>
+      </p:sp>
+      <p:sp>
+        <p:nvSpPr>
+          <p:cNvPr id="17" name="Shape 15"/>
+          <p:cNvSpPr/>
+          <p:nvPr/>
+        </p:nvSpPr>
+        <p:spPr>
+          <a:xfrm>
+            <a:off x="4480560" y="1828800"/>
+            <a:ext cx="502920" cy="502920"/>
+          </a:xfrm>
+          <a:prstGeom prst="ellipse">
+            <a:avLst/>
+          </a:prstGeom>
+          <a:solidFill>
+            <a:srgbClr val="1B4965"/>
+          </a:solidFill>
+          <a:ln/>
+        </p:spPr>
+        <p:txBody>
+          <a:bodyPr/>
+          <a:p/>
+        </p:txBody>
+      </p:sp>
+      <p:sp>
+        <p:nvSpPr>
+          <p:cNvPr id="18" name="Text 16"/>
+          <p:cNvSpPr/>
+          <p:nvPr/>
+        </p:nvSpPr>
+        <p:spPr>
+          <a:xfrm>
+            <a:off x="4480560" y="1828800"/>
+            <a:ext cx="502920" cy="502920"/>
+          </a:xfrm>
+          <a:prstGeom prst="rect">
+            <a:avLst/>
+          </a:prstGeom>
+          <a:noFill/>
+          <a:ln/>
+        </p:spPr>
+        <p:txBody>
+          <a:bodyPr wrap="square" rtlCol="0" anchor="ctr"/>
+          <a:lstStyle/>
+          <a:p>
+            <a:pPr algn="ctr" indent="0" marL="0">
+              <a:buNone/>
+            </a:pPr>
+            <a:r>
+              <a:rPr lang="en-US" sz="1700" b="1" dirty="0">
+                <a:solidFill>
+                  <a:srgbClr val="F7931A"/>
+                </a:solidFill>
+                <a:latin typeface="Cambria" pitchFamily="34" charset="0"/>
+                <a:ea typeface="Cambria" pitchFamily="34" charset="-122"/>
+                <a:cs typeface="Cambria" pitchFamily="34" charset="-120"/>
+              </a:rPr>
+              <a:t>2</a:t>
+            </a:r>
+            <a:endParaRPr lang="en-US" sz="1700" dirty="0"/>
+          </a:p>
+        </p:txBody>
+      </p:sp>
+      <p:sp>
+        <p:nvSpPr>
+          <p:cNvPr id="19" name="Text 17"/>
+          <p:cNvSpPr/>
+          <p:nvPr/>
+        </p:nvSpPr>
+        <p:spPr>
+          <a:xfrm>
+            <a:off x="3566160" y="2450592"/>
+            <a:ext cx="2331720" cy="320040"/>
+          </a:xfrm>
+          <a:prstGeom prst="rect">
+            <a:avLst/>
+          </a:prstGeom>
+          <a:noFill/>
+          <a:ln/>
+        </p:spPr>
+        <p:txBody>
+          <a:bodyPr wrap="square" rtlCol="0" anchor="ctr"/>
+          <a:lstStyle/>
+          <a:p>
+            <a:pPr algn="ctr" indent="0" marL="0">
+              <a:buNone/>
+            </a:pPr>
+            <a:r>
+              <a:rPr lang="en-US" sz="1300" b="1" dirty="0">
+                <a:solidFill>
+                  <a:srgbClr val="0D1B2A"/>
+                </a:solidFill>
+                <a:latin typeface="Cambria" pitchFamily="34" charset="0"/>
+                <a:ea typeface="Cambria" pitchFamily="34" charset="-122"/>
+                <a:cs typeface="Cambria" pitchFamily="34" charset="-120"/>
+              </a:rPr>
+              <a:t>Price a hypothetical option</a:t>
+            </a:r>
+            <a:endParaRPr lang="en-US" sz="1300" dirty="0"/>
+          </a:p>
+        </p:txBody>
+      </p:sp>
+      <p:sp>
+        <p:nvSpPr>
+          <p:cNvPr id="20" name="Text 18"/>
+          <p:cNvSpPr/>
+          <p:nvPr/>
+        </p:nvSpPr>
+        <p:spPr>
+          <a:xfrm>
+            <a:off x="3566160" y="2788920"/>
+            <a:ext cx="2331720" cy="1097280"/>
+          </a:xfrm>
+          <a:prstGeom prst="rect">
+            <a:avLst/>
+          </a:prstGeom>
+          <a:noFill/>
+          <a:ln/>
+        </p:spPr>
+        <p:txBody>
+          <a:bodyPr wrap="square" rtlCol="0" anchor="t"/>
+          <a:lstStyle/>
+          <a:p>
+            <a:pPr algn="ctr" indent="0" marL="0">
+              <a:lnSpc>
+                <a:spcPct val="110000"/>
+              </a:lnSpc>
+              <a:buNone/>
+            </a:pPr>
+            <a:r>
+              <a:rPr lang="en-US" sz="1100" dirty="0">
+                <a:solidFill>
+                  <a:srgbClr val="0D1B2A"/>
+                </a:solidFill>
+                <a:latin typeface="Calibri" pitchFamily="34" charset="0"/>
+                <a:ea typeface="Calibri" pitchFamily="34" charset="-122"/>
+                <a:cs typeface="Calibri" pitchFamily="34" charset="-120"/>
+              </a:rPr>
+              <a:t>A 7-day BTC option priced at that 44% figure is worth about $1,177 — the model's own fair-value estimate.</a:t>
+            </a:r>
+            <a:endParaRPr lang="en-US" sz="1100" dirty="0"/>
+          </a:p>
+        </p:txBody>
+      </p:sp>
+      <p:sp>
+        <p:nvSpPr>
+          <p:cNvPr id="21" name="Shape 19"/>
+          <p:cNvSpPr/>
+          <p:nvPr/>
+        </p:nvSpPr>
+        <p:spPr>
+          <a:xfrm>
+            <a:off x="6217920" y="1645920"/>
+            <a:ext cx="2697480" cy="2377440"/>
+          </a:xfrm>
+          <a:prstGeom prst="roundRect">
+            <a:avLst>
+              <a:gd name="adj" fmla="val 3077"/>
+            </a:avLst>
+          </a:prstGeom>
+          <a:solidFill>
+            <a:srgbClr val="FFFFFF"/>
+          </a:solidFill>
+          <a:ln w="12700">
+            <a:solidFill>
+              <a:srgbClr val="CADCFC"/>
+            </a:solidFill>
+            <a:prstDash val="solid"/>
+          </a:ln>
+        </p:spPr>
+        <p:txBody>
+          <a:bodyPr/>
+          <a:p/>
+        </p:txBody>
+      </p:sp>
+      <p:sp>
+        <p:nvSpPr>
+          <p:cNvPr id="22" name="Shape 20"/>
+          <p:cNvSpPr/>
+          <p:nvPr/>
+        </p:nvSpPr>
+        <p:spPr>
+          <a:xfrm>
+            <a:off x="7315200" y="1828800"/>
+            <a:ext cx="502920" cy="502920"/>
+          </a:xfrm>
+          <a:prstGeom prst="ellipse">
+            <a:avLst/>
+          </a:prstGeom>
+          <a:solidFill>
+            <a:srgbClr val="1B4965"/>
+          </a:solidFill>
+          <a:ln/>
+        </p:spPr>
+        <p:txBody>
+          <a:bodyPr/>
+          <a:p/>
+        </p:txBody>
+      </p:sp>
+      <p:sp>
+        <p:nvSpPr>
+          <p:cNvPr id="23" name="Text 21"/>
+          <p:cNvSpPr/>
+          <p:nvPr/>
+        </p:nvSpPr>
+        <p:spPr>
+          <a:xfrm>
+            <a:off x="7315200" y="1828800"/>
+            <a:ext cx="502920" cy="502920"/>
+          </a:xfrm>
+          <a:prstGeom prst="rect">
+            <a:avLst/>
+          </a:prstGeom>
+          <a:noFill/>
+          <a:ln/>
+        </p:spPr>
+        <p:txBody>
+          <a:bodyPr wrap="square" rtlCol="0" anchor="ctr"/>
+          <a:lstStyle/>
+          <a:p>
+            <a:pPr algn="ctr" indent="0" marL="0">
+              <a:buNone/>
+            </a:pPr>
+            <a:r>
+              <a:rPr lang="en-US" sz="1700" b="1" dirty="0">
+                <a:solidFill>
+                  <a:srgbClr val="F7931A"/>
+                </a:solidFill>
+                <a:latin typeface="Cambria" pitchFamily="34" charset="0"/>
+                <a:ea typeface="Cambria" pitchFamily="34" charset="-122"/>
+                <a:cs typeface="Cambria" pitchFamily="34" charset="-120"/>
+              </a:rPr>
+              <a:t>3</a:t>
+            </a:r>
+            <a:endParaRPr lang="en-US" sz="1700" dirty="0"/>
+          </a:p>
+        </p:txBody>
+      </p:sp>
+      <p:sp>
+        <p:nvSpPr>
+          <p:cNvPr id="24" name="Text 22"/>
+          <p:cNvSpPr/>
+          <p:nvPr/>
+        </p:nvSpPr>
+        <p:spPr>
+          <a:xfrm>
+            <a:off x="6400800" y="2450592"/>
+            <a:ext cx="2331720" cy="320040"/>
+          </a:xfrm>
+          <a:prstGeom prst="rect">
+            <a:avLst/>
+          </a:prstGeom>
+          <a:noFill/>
+          <a:ln/>
+        </p:spPr>
+        <p:txBody>
+          <a:bodyPr wrap="square" rtlCol="0" anchor="ctr"/>
+          <a:lstStyle/>
+          <a:p>
+            <a:pPr algn="ctr" indent="0" marL="0">
+              <a:buNone/>
+            </a:pPr>
+            <a:r>
+              <a:rPr lang="en-US" sz="1300" b="1" dirty="0">
+                <a:solidFill>
+                  <a:srgbClr val="0D1B2A"/>
+                </a:solidFill>
+                <a:latin typeface="Cambria" pitchFamily="34" charset="0"/>
+                <a:ea typeface="Cambria" pitchFamily="34" charset="-122"/>
+                <a:cs typeface="Cambria" pitchFamily="34" charset="-120"/>
+              </a:rPr>
+              <a:t>Compare to market pricing</a:t>
+            </a:r>
+            <a:endParaRPr lang="en-US" sz="1300" dirty="0"/>
+          </a:p>
+        </p:txBody>
+      </p:sp>
+      <p:sp>
+        <p:nvSpPr>
+          <p:cNvPr id="25" name="Text 23"/>
+          <p:cNvSpPr/>
+          <p:nvPr/>
+        </p:nvSpPr>
+        <p:spPr>
+          <a:xfrm>
+            <a:off x="6400800" y="2788920"/>
+            <a:ext cx="2331720" cy="1097280"/>
+          </a:xfrm>
+          <a:prstGeom prst="rect">
+            <a:avLst/>
+          </a:prstGeom>
+          <a:noFill/>
+          <a:ln/>
+        </p:spPr>
+        <p:txBody>
+          <a:bodyPr wrap="square" rtlCol="0" anchor="t"/>
+          <a:lstStyle/>
+          <a:p>
+            <a:pPr algn="ctr" indent="0" marL="0">
+              <a:lnSpc>
+                <a:spcPct val="110000"/>
+              </a:lnSpc>
+              <a:buNone/>
+            </a:pPr>
+            <a:r>
+              <a:rPr lang="en-US" sz="1100" dirty="0">
+                <a:solidFill>
+                  <a:srgbClr val="0D1B2A"/>
+                </a:solidFill>
+                <a:latin typeface="Calibri" pitchFamily="34" charset="0"/>
+                <a:ea typeface="Calibri" pitchFamily="34" charset="-122"/>
+                <a:cs typeface="Calibri" pitchFamily="34" charset="-120"/>
+              </a:rPr>
+              <a:t>If the market prices that same option using 50% volatility instead, it comes out near $1,454 — about $280 more expensive than the model suggests is fair.</a:t>
+            </a:r>
+            <a:endParaRPr lang="en-US" sz="1100" dirty="0"/>
+          </a:p>
+        </p:txBody>
+      </p:sp>
+      <p:sp>
+        <p:nvSpPr>
+          <p:cNvPr id="26" name="Shape 24"/>
+          <p:cNvSpPr/>
+          <p:nvPr/>
+        </p:nvSpPr>
+        <p:spPr>
+          <a:xfrm>
+            <a:off x="9052560" y="1645920"/>
+            <a:ext cx="2697480" cy="2377440"/>
+          </a:xfrm>
+          <a:prstGeom prst="roundRect">
+            <a:avLst>
+              <a:gd name="adj" fmla="val 3077"/>
+            </a:avLst>
+          </a:prstGeom>
+          <a:solidFill>
+            <a:srgbClr val="FFFFFF"/>
+          </a:solidFill>
+          <a:ln w="12700">
+            <a:solidFill>
+              <a:srgbClr val="CADCFC"/>
+            </a:solidFill>
+            <a:prstDash val="solid"/>
+          </a:ln>
+        </p:spPr>
+        <p:txBody>
+          <a:bodyPr/>
+          <a:p/>
+        </p:txBody>
+      </p:sp>
+      <p:sp>
+        <p:nvSpPr>
+          <p:cNvPr id="27" name="Shape 25"/>
+          <p:cNvSpPr/>
+          <p:nvPr/>
+        </p:nvSpPr>
+        <p:spPr>
+          <a:xfrm>
+            <a:off x="10149840" y="1828800"/>
+            <a:ext cx="502920" cy="502920"/>
+          </a:xfrm>
+          <a:prstGeom prst="ellipse">
+            <a:avLst/>
+          </a:prstGeom>
+          <a:solidFill>
+            <a:srgbClr val="1B4965"/>
+          </a:solidFill>
+          <a:ln/>
+        </p:spPr>
+        <p:txBody>
+          <a:bodyPr/>
+          <a:p/>
+        </p:txBody>
+      </p:sp>
+      <p:sp>
+        <p:nvSpPr>
+          <p:cNvPr id="28" name="Text 26"/>
+          <p:cNvSpPr/>
+          <p:nvPr/>
+        </p:nvSpPr>
+        <p:spPr>
+          <a:xfrm>
+            <a:off x="10149840" y="1828800"/>
+            <a:ext cx="502920" cy="502920"/>
+          </a:xfrm>
+          <a:prstGeom prst="rect">
+            <a:avLst/>
+          </a:prstGeom>
+          <a:noFill/>
+          <a:ln/>
+        </p:spPr>
+        <p:txBody>
+          <a:bodyPr wrap="square" rtlCol="0" anchor="ctr"/>
+          <a:lstStyle/>
+          <a:p>
+            <a:pPr algn="ctr" indent="0" marL="0">
+              <a:buNone/>
+            </a:pPr>
+            <a:r>
+              <a:rPr lang="en-US" sz="1700" b="1" dirty="0">
+                <a:solidFill>
+                  <a:srgbClr val="F7931A"/>
+                </a:solidFill>
+                <a:latin typeface="Cambria" pitchFamily="34" charset="0"/>
+                <a:ea typeface="Cambria" pitchFamily="34" charset="-122"/>
+                <a:cs typeface="Cambria" pitchFamily="34" charset="-120"/>
+              </a:rPr>
+              <a:t>4</a:t>
+            </a:r>
+            <a:endParaRPr lang="en-US" sz="1700" dirty="0"/>
+          </a:p>
+        </p:txBody>
+      </p:sp>
+      <p:sp>
+        <p:nvSpPr>
+          <p:cNvPr id="29" name="Text 27"/>
+          <p:cNvSpPr/>
+          <p:nvPr/>
+        </p:nvSpPr>
+        <p:spPr>
+          <a:xfrm>
+            <a:off x="9235440" y="2450592"/>
+            <a:ext cx="2331720" cy="320040"/>
+          </a:xfrm>
+          <a:prstGeom prst="rect">
+            <a:avLst/>
+          </a:prstGeom>
+          <a:noFill/>
+          <a:ln/>
+        </p:spPr>
+        <p:txBody>
+          <a:bodyPr wrap="square" rtlCol="0" anchor="ctr"/>
+          <a:lstStyle/>
+          <a:p>
+            <a:pPr algn="ctr" indent="0" marL="0">
+              <a:buNone/>
+            </a:pPr>
+            <a:r>
+              <a:rPr lang="en-US" sz="1300" b="1" dirty="0">
+                <a:solidFill>
+                  <a:srgbClr val="0D1B2A"/>
+                </a:solidFill>
+                <a:latin typeface="Cambria" pitchFamily="34" charset="0"/>
+                <a:ea typeface="Cambria" pitchFamily="34" charset="-122"/>
+                <a:cs typeface="Cambria" pitchFamily="34" charset="-120"/>
+              </a:rPr>
+              <a:t>Spot the opportunity</a:t>
+            </a:r>
+            <a:endParaRPr lang="en-US" sz="1300" dirty="0"/>
+          </a:p>
+        </p:txBody>
+      </p:sp>
+      <p:sp>
+        <p:nvSpPr>
+          <p:cNvPr id="30" name="Text 28"/>
+          <p:cNvSpPr/>
+          <p:nvPr/>
+        </p:nvSpPr>
+        <p:spPr>
+          <a:xfrm>
+            <a:off x="9235440" y="2788920"/>
+            <a:ext cx="2331720" cy="1097280"/>
+          </a:xfrm>
+          <a:prstGeom prst="rect">
+            <a:avLst/>
+          </a:prstGeom>
+          <a:noFill/>
+          <a:ln/>
+        </p:spPr>
+        <p:txBody>
+          <a:bodyPr wrap="square" rtlCol="0" anchor="t"/>
+          <a:lstStyle/>
+          <a:p>
+            <a:pPr algn="ctr" indent="0" marL="0">
+              <a:lnSpc>
+                <a:spcPct val="110000"/>
+              </a:lnSpc>
+              <a:buNone/>
+            </a:pPr>
+            <a:r>
+              <a:rPr lang="en-US" sz="1100" dirty="0">
+                <a:solidFill>
+                  <a:srgbClr val="0D1B2A"/>
+                </a:solidFill>
+                <a:latin typeface="Calibri" pitchFamily="34" charset="0"/>
+                <a:ea typeface="Calibri" pitchFamily="34" charset="-122"/>
+                <a:cs typeface="Calibri" pitchFamily="34" charset="-120"/>
+              </a:rPr>
+              <a:t>Pricier than the model expects may be worth selling; cheaper (e.g. a 35% assumption, ~$792) may be worth buying — always alongside the market's own price, never instead of it.</a:t>
+            </a:r>
+            <a:endParaRPr lang="en-US" sz="1100" dirty="0"/>
+          </a:p>
+        </p:txBody>
+      </p:sp>
+      <p:sp>
+        <p:nvSpPr>
+          <p:cNvPr id="31" name="Shape 29"/>
+          <p:cNvSpPr/>
+          <p:nvPr/>
+        </p:nvSpPr>
+        <p:spPr>
+          <a:xfrm>
+            <a:off x="548640" y="4297680"/>
+            <a:ext cx="11064240" cy="1737360"/>
+          </a:xfrm>
+          <a:prstGeom prst="roundRect">
+            <a:avLst>
+              <a:gd name="adj" fmla="val 4211"/>
+            </a:avLst>
+          </a:prstGeom>
+          <a:solidFill>
+            <a:srgbClr val="0D1B2A"/>
+          </a:solidFill>
+          <a:ln/>
+        </p:spPr>
+        <p:txBody>
+          <a:bodyPr/>
+          <a:p/>
+        </p:txBody>
+      </p:sp>
+      <p:sp>
+        <p:nvSpPr>
+          <p:cNvPr id="32" name="Text 30"/>
+          <p:cNvSpPr/>
+          <p:nvPr/>
+        </p:nvSpPr>
+        <p:spPr>
+          <a:xfrm>
+            <a:off x="868680" y="4480560"/>
+            <a:ext cx="10424160" cy="320040"/>
+          </a:xfrm>
+          <a:prstGeom prst="rect">
+            <a:avLst/>
+          </a:prstGeom>
+          <a:noFill/>
+          <a:ln/>
+        </p:spPr>
+        <p:txBody>
+          <a:bodyPr wrap="square" rtlCol="0" anchor="ctr"/>
+          <a:lstStyle/>
+          <a:p>
+            <a:pPr indent="0" marL="0">
+              <a:buNone/>
+            </a:pPr>
+            <a:r>
+              <a:rPr lang="en-US" sz="1500" b="1" dirty="0">
+                <a:solidFill>
+                  <a:srgbClr val="F7931A"/>
+                </a:solidFill>
+                <a:latin typeface="Cambria" pitchFamily="34" charset="0"/>
+                <a:ea typeface="Cambria" pitchFamily="34" charset="-122"/>
+                <a:cs typeface="Cambria" pitchFamily="34" charset="-120"/>
+              </a:rPr>
+              <a:t>Why this is a signal, not a system</a:t>
+            </a:r>
+            <a:endParaRPr lang="en-US" sz="1500" dirty="0"/>
+          </a:p>
+        </p:txBody>
+      </p:sp>
+      <p:sp>
+        <p:nvSpPr>
+          <p:cNvPr id="33" name="Text 31"/>
+          <p:cNvSpPr/>
+          <p:nvPr/>
+        </p:nvSpPr>
+        <p:spPr>
+          <a:xfrm>
+            <a:off x="868680" y="4846320"/>
+            <a:ext cx="10424160" cy="1051560"/>
+          </a:xfrm>
+          <a:prstGeom prst="rect">
+            <a:avLst/>
+          </a:prstGeom>
+          <a:noFill/>
+          <a:ln/>
+        </p:spPr>
+        <p:txBody>
+          <a:bodyPr wrap="square" rtlCol="0" anchor="t"/>
+          <a:lstStyle/>
+          <a:p>
+            <a:pPr indent="0" marL="0">
+              <a:lnSpc>
+                <a:spcPct val="120000"/>
+              </a:lnSpc>
+              <a:buNone/>
+            </a:pPr>
+            <a:r>
+              <a:rPr lang="en-US" sz="1300" dirty="0">
+                <a:solidFill>
+                  <a:srgbClr val="FFFFFF"/>
+                </a:solidFill>
+                <a:latin typeface="Calibri" pitchFamily="34" charset="0"/>
+                <a:ea typeface="Calibri" pitchFamily="34" charset="-122"/>
+                <a:cs typeface="Calibri" pitchFamily="34" charset="-120"/>
+              </a:rPr>
+              <a:t>This never overrides a liquid market's own quoted price. It's most useful when no market price exists at all, or for spotting relative mispricing — and even then, it would be sized carefully and combined with other information, not traded on alone.</a:t>
+            </a:r>
+            <a:endParaRPr lang="en-US" sz="1300" dirty="0"/>
+          </a:p>
+        </p:txBody>
+      </p:sp>
+    </p:spTree>
+  </p:cSld>
+  <p:clrMapOvr>
+    <a:masterClrMapping/>
+  </p:clrMapOvr>
+</p:sld>
+</file>
+
+<file path=ppt/slides/slide17.xml><?xml version="1.0" encoding="utf-8"?>
 <p:sld xmlns:a="http://schemas.openxmlformats.org/drawingml/2006/main" xmlns:r="http://schemas.openxmlformats.org/officeDocument/2006/relationships" xmlns:p="http://schemas.openxmlformats.org/presentationml/2006/main">
   <p:cSld name="Slide 13">
     <p:bg>

</xml_diff>

<commit_message>
Propagate Check 19 (Mincer-Zarnowitz R² diagnostic) into report and deck
Report: new paragraph in Section 7.6 documenting the check, plus a
cross-reference from Section 8.1's R² discussion. Deck: new Limitations
bullet on slide 14 noting this notebook's R² is scikit-learn's stricter
convention, and that the literature's own Mincer-Zarnowitz convention
scores the same model higher (0.27 historical / 0.24 live).
</commit_message>
<xml_diff>
--- a/presentation/capstone-btc-volatility.pptx
+++ b/presentation/capstone-btc-volatility.pptx
@@ -10457,6 +10457,30 @@
                 <a:cs typeface="Calibri" pitchFamily="34" charset="-120"/>
               </a:rPr>
               <a:t>Single asset: no cross-asset spillover signal from other coins is used</a:t>
+            </a:r>
+            <a:endParaRPr lang="en-US" sz="1100" dirty="0"/>
+          </a:p>
+          <a:p>
+            <a:pPr marL="342900" indent="-342900">
+              <a:lnSpc>
+                <a:spcPct val="115000"/>
+              </a:lnSpc>
+              <a:spcAft>
+                <a:spcPts val="1000"/>
+              </a:spcAft>
+              <a:buSzPct val="100000"/>
+              <a:buChar char="●"/>
+            </a:pPr>
+            <a:r>
+              <a:rPr lang="en-US" sz="1100" dirty="0">
+                <a:solidFill>
+                  <a:srgbClr val="0D1B2A"/>
+                </a:solidFill>
+                <a:latin typeface="Calibri" pitchFamily="34" charset="0"/>
+                <a:ea typeface="Calibri" pitchFamily="34" charset="-122"/>
+                <a:cs typeface="Calibri" pitchFamily="34" charset="-120"/>
+              </a:rPr>
+              <a:t>Check 19: this notebook's stricter scikit-learn R² vs. the literature's own Mincer-Zarnowitz convention — recomputed that way, HAR-RV-X scores higher (0.27 historical / 0.24 live)</a:t>
             </a:r>
             <a:endParaRPr lang="en-US" sz="1100" dirty="0"/>
           </a:p>

</xml_diff>

<commit_message>
Propagate Checks 20-22 (ARIMA, ARIMAX, LSTM classifier) into report and deck
Report: three new paragraphs in Section 7.6 covering each check's setup,
result, and interpretation - including the LSTM classifier's below-
majority-baseline accuracy finding and its regime-shift diagnosis.

Deck: slide 14's robustness-check count updated to twenty-two, and the
standalone Check 19 bullet consolidated into a combined Checks 19-22
bullet to fit the card without overflow.
</commit_message>
<xml_diff>
--- a/presentation/capstone-btc-volatility.pptx
+++ b/presentation/capstone-btc-volatility.pptx
@@ -10432,7 +10432,7 @@
                 <a:ea typeface="Calibri" pitchFamily="34" charset="-122"/>
                 <a:cs typeface="Calibri" pitchFamily="34" charset="-120"/>
               </a:rPr>
-              <a:t>Eighteen robustness checks tested (XGBoost, LSTM, stacked ensembles, ETH spillover, winsorizing, and more) — four survived validation and were adopted, fourteen didn't</a:t>
+              <a:t>Twenty-two robustness checks tested (XGBoost, LSTM, ARIMA/ARIMAX, stacked ensembles, ETH spillover, winsorizing, and more) - four survived validation and were adopted, the rest didn't</a:t>
             </a:r>
             <a:endParaRPr lang="en-US" sz="1100" dirty="0"/>
           </a:p>
@@ -10480,7 +10480,7 @@
                 <a:ea typeface="Calibri" pitchFamily="34" charset="-122"/>
                 <a:cs typeface="Calibri" pitchFamily="34" charset="-120"/>
               </a:rPr>
-              <a:t>Check 19: this notebook's stricter scikit-learn R² vs. the literature's own Mincer-Zarnowitz convention — recomputed that way, HAR-RV-X scores higher (0.27 historical / 0.24 live)</a:t>
+              <a:t>Checks 19-22: R² here is a stricter convention than the literature's; ARIMA, ARIMAX, and an LSTM classifier also didn't beat HAR-RV-X (Final)</a:t>
             </a:r>
             <a:endParaRPr lang="en-US" sz="1100" dirty="0"/>
           </a:p>

</xml_diff>